<commit_message>
Preview: revenue per $1 of fixed ops net profit, smaller fixed expense tile text
Co-Authored-By: Claude Opus 5.5 <noreply@anthropic.com>
Claude-Session: https://claude.ai/code/session_01Xa4nFVxuQGXmHARGph9WhS
</commit_message>
<xml_diff>
--- a/day2-deck/decks/Fixed Absorption & Net Profit - Preview.pptx
+++ b/day2-deck/decks/Fixed Absorption & Net Profit - Preview.pptx
@@ -2553,7 +2553,7 @@
           <a:p>
             <a:r>
               <a:rPr lang="en-US" dirty="0"/>
-              <a:t>Source: Qlik - Profit &amp; Loss, Detail statement. Same-store, INEOS excluded (opened 2026). Fixed ops net profit = service (Mechanical) + parts (P&amp;A) department profit: department gross less the department's own expenses; GMC Prescott body shop is its own department and is not included.PREVIEW (Noah, Oct 24). Department profit as the P&amp;L Detail statement reports it (DEPARTMENT PROFIT OR LOSS, Mechanical and P&amp;A). Jan-Sep 2026 gross $188,799,724, department expenses $138,349,830, profit $50,449,894; 2025 $181,331,157 / $135,995,022 / $45,336,135. Store-level costs the P&amp;L does not split by department (management fees, other income) sit outside it. Same basis as the service and parts net to gross slides.</a:t>
+              <a:t>Source: Qlik - Profit &amp; Loss, Detail statement. Same-store, INEOS excluded (opened 2026). Fixed ops net profit = service (Mechanical) + parts (P&amp;A) department profit: department gross less the department's own expenses; GMC Prescott body shop is its own department and is not included.PREVIEW (Noah, Oct 24). Department profit as the P&amp;L Detail statement reports it (DEPARTMENT PROFIT OR LOSS, Mechanical and P&amp;A). Jan-Sep 2026 gross $188,799,724, department expenses $138,349,830, profit $50,449,894; 2025 $181,331,157 / $135,995,022 / $45,336,135. Store-level costs the P&amp;L does not split by department (management fees, other income) sit outside it. Same basis as the service and parts net to gross slides. Revenue per $1 of net: service + parts net sales $347,806,562 (P&amp;L Detail NET SALES, Mechanical $182,131,162 + P&amp;A $165,675,400) / net profit $50,449,894 = $6.89; net profit is 14.5 cents of every sales dollar. Parts sales include parts sold to the service department.</a:t>
             </a:r>
             <a:endParaRPr lang="en-US" dirty="0"/>
           </a:p>
@@ -4592,7 +4592,7 @@
               <a:buNone/>
             </a:pPr>
             <a:r>
-              <a:rPr lang="en-US" sz="1500" dirty="0">
+              <a:rPr lang="en-US" sz="1400" dirty="0">
                 <a:solidFill>
                   <a:srgbClr val="1A1A1A"/>
                 </a:solidFill>
@@ -4600,9 +4600,9 @@
                 <a:ea typeface="Inter" pitchFamily="34" charset="-122"/>
                 <a:cs typeface="Inter" pitchFamily="34" charset="-120"/>
               </a:rPr>
-              <a:t>61% · Salaries and wages (managers, advisors, techs, porters, office), payroll taxes, benefits, PTO</a:t>
-            </a:r>
-            <a:endParaRPr lang="en-US" sz="1500" dirty="0"/>
+              <a:t>61% · Salaries and wages, payroll taxes, benefits, PTO</a:t>
+            </a:r>
+            <a:endParaRPr lang="en-US" sz="1400" dirty="0"/>
           </a:p>
         </p:txBody>
       </p:sp>
@@ -4751,7 +4751,7 @@
               <a:buNone/>
             </a:pPr>
             <a:r>
-              <a:rPr lang="en-US" sz="1500" dirty="0">
+              <a:rPr lang="en-US" sz="1400" dirty="0">
                 <a:solidFill>
                   <a:srgbClr val="1A1A1A"/>
                 </a:solidFill>
@@ -4761,7 +4761,7 @@
               </a:rPr>
               <a:t>16% · Rent, depreciation, property taxes, utilities, insurance, building and equipment repairs</a:t>
             </a:r>
-            <a:endParaRPr lang="en-US" sz="1500" dirty="0"/>
+            <a:endParaRPr lang="en-US" sz="1400" dirty="0"/>
           </a:p>
         </p:txBody>
       </p:sp>
@@ -4910,7 +4910,7 @@
               <a:buNone/>
             </a:pPr>
             <a:r>
-              <a:rPr lang="en-US" sz="1500" dirty="0">
+              <a:rPr lang="en-US" sz="1400" dirty="0">
                 <a:solidFill>
                   <a:srgbClr val="1A1A1A"/>
                 </a:solidFill>
@@ -4920,7 +4920,7 @@
               </a:rPr>
               <a:t>15% · DMS and IT, outside services, phones, legal and audit</a:t>
             </a:r>
-            <a:endParaRPr lang="en-US" sz="1500" dirty="0"/>
+            <a:endParaRPr lang="en-US" sz="1400" dirty="0"/>
           </a:p>
         </p:txBody>
       </p:sp>
@@ -5069,7 +5069,7 @@
               <a:buNone/>
             </a:pPr>
             <a:r>
-              <a:rPr lang="en-US" sz="1500" dirty="0">
+              <a:rPr lang="en-US" sz="1400" dirty="0">
                 <a:solidFill>
                   <a:srgbClr val="1A1A1A"/>
                 </a:solidFill>
@@ -5079,7 +5079,7 @@
               </a:rPr>
               <a:t>8% · Service and parts advertising, training, company vehicles, freight, supplies, travel, other taxes</a:t>
             </a:r>
-            <a:endParaRPr lang="en-US" sz="1500" dirty="0"/>
+            <a:endParaRPr lang="en-US" sz="1400" dirty="0"/>
           </a:p>
         </p:txBody>
       </p:sp>
@@ -5943,7 +5943,7 @@
                 <a:ea typeface="Inter" pitchFamily="34" charset="-122"/>
                 <a:cs typeface="Inter" pitchFamily="34" charset="-120"/>
               </a:rPr>
-              <a:t>Every dollar of expense saved drops straight to the bottom line.</a:t>
+              <a:t>Every dollar of expense saved drops straight to the bottom line. Adding that same $1 through sales takes about $6.89 of service and parts sales.</a:t>
             </a:r>
             <a:endParaRPr lang="en-US" sz="1500" dirty="0"/>
           </a:p>

</xml_diff>

<commit_message>
Preview: fixed expense tiles to one decimal
Co-Authored-By: Claude Opus 5.5 <noreply@anthropic.com>
Claude-Session: https://claude.ai/code/session_01Xa4nFVxuQGXmHARGph9WhS
</commit_message>
<xml_diff>
--- a/day2-deck/decks/Fixed Absorption & Net Profit - Preview.pptx
+++ b/day2-deck/decks/Fixed Absorption & Net Profit - Preview.pptx
@@ -4561,7 +4561,7 @@
                 <a:ea typeface="Inter" pitchFamily="34" charset="-122"/>
                 <a:cs typeface="Inter" pitchFamily="34" charset="-120"/>
               </a:rPr>
-              <a:t>$147.85M</a:t>
+              <a:t>$147.9M</a:t>
             </a:r>
             <a:endParaRPr lang="en-US" sz="3600" dirty="0"/>
           </a:p>
@@ -4720,7 +4720,7 @@
                 <a:ea typeface="Inter" pitchFamily="34" charset="-122"/>
                 <a:cs typeface="Inter" pitchFamily="34" charset="-120"/>
               </a:rPr>
-              <a:t>$39.08M</a:t>
+              <a:t>$39.1M</a:t>
             </a:r>
             <a:endParaRPr lang="en-US" sz="3600" dirty="0"/>
           </a:p>
@@ -4879,7 +4879,7 @@
                 <a:ea typeface="Inter" pitchFamily="34" charset="-122"/>
                 <a:cs typeface="Inter" pitchFamily="34" charset="-120"/>
               </a:rPr>
-              <a:t>$36.40M</a:t>
+              <a:t>$36.4M</a:t>
             </a:r>
             <a:endParaRPr lang="en-US" sz="3600" dirty="0"/>
           </a:p>
@@ -5038,7 +5038,7 @@
                 <a:ea typeface="Inter" pitchFamily="34" charset="-122"/>
                 <a:cs typeface="Inter" pitchFamily="34" charset="-120"/>
               </a:rPr>
-              <a:t>$19.52M</a:t>
+              <a:t>$19.5M</a:t>
             </a:r>
             <a:endParaRPr lang="en-US" sz="3600" dirty="0"/>
           </a:p>
@@ -5175,7 +5175,7 @@
                 <a:ea typeface="Inter" pitchFamily="34" charset="-122"/>
                 <a:cs typeface="Inter" pitchFamily="34" charset="-120"/>
               </a:rPr>
-              <a:t>$242.85M of fixed expenses Jan-Sep 2026; fixed ops gross of $189.67M covers 78.1% of it. People are 61% of the total.</a:t>
+              <a:t>$242.9M of fixed expenses Jan-Sep 2026; fixed ops gross of $189.7M covers 78.1% of it. People are 61% of the total.</a:t>
             </a:r>
             <a:endParaRPr lang="en-US" sz="1600" dirty="0"/>
           </a:p>

</xml_diff>

<commit_message>
Preview: net profit % change over the absolute 2025 base (no n/m)
Co-Authored-By: Claude Opus 5.5 <noreply@anthropic.com>
Claude-Session: https://claude.ai/code/session_01Xa4nFVxuQGXmHARGph9WhS
</commit_message>
<xml_diff>
--- a/day2-deck/decks/Fixed Absorption & Net Profit - Preview.pptx
+++ b/day2-deck/decks/Fixed Absorption & Net Profit - Preview.pptx
@@ -2817,7 +2817,7 @@
           <a:p>
             <a:r>
               <a:rPr lang="en-US" dirty="0"/>
-              <a:t>Source: Qlik - Profit &amp; Loss, Detail statement. Same-store, INEOS excluded (opened 2026). Fixed ops net profit = service (Mechanical) + parts (P&amp;A) department profit: department gross less the department's own expenses; GMC Prescott body shop is its own department and is not included. Ranked by dollar change, Jan-Sep 2026 vs Jan-Sep 2025; percent change alongside, top three and bottom three by percent marked. n/m: the store lost money in fixed ops in 2025, so a percent change has no meaning.</a:t>
+              <a:t>Source: Qlik - Profit &amp; Loss, Detail statement. Same-store, INEOS excluded (opened 2026). Fixed ops net profit = service (Mechanical) + parts (P&amp;A) department profit: department gross less the department's own expenses; GMC Prescott body shop is its own department and is not included. Ranked by dollar change, Jan-Sep 2026 vs Jan-Sep 2025; percent change alongside, top three and bottom three by percent marked. Percent change = dollar change / 2025 profit; where 2025 was a loss, divided by the size of the loss, so an improvement reads as positive.</a:t>
             </a:r>
             <a:endParaRPr lang="en-US" dirty="0"/>
           </a:p>
@@ -13410,7 +13410,7 @@
                 <a:ea typeface="Inter" pitchFamily="34" charset="-122"/>
                 <a:cs typeface="Inter" pitchFamily="34" charset="-120"/>
               </a:rPr>
-              <a:t>n/m</a:t>
+              <a:t>+124.3%</a:t>
             </a:r>
             <a:endParaRPr lang="en-US" sz="1200" dirty="0"/>
           </a:p>
@@ -14318,14 +14318,92 @@
       </p:sp>
       <p:sp>
         <p:nvSpPr>
-          <p:cNvPr id="66" name="Shape 64"/>
+          <p:cNvPr id="66" name="Text 64"/>
+          <p:cNvSpPr txBox="1"/>
+          <p:nvPr/>
+        </p:nvSpPr>
+        <p:spPr>
+          <a:xfrm>
+            <a:off x="658368" y="4358999"/>
+            <a:ext cx="310896" cy="223759"/>
+          </a:xfrm>
+          <a:prstGeom prst="rect">
+            <a:avLst/>
+          </a:prstGeom>
+          <a:noFill/>
+          <a:ln/>
+        </p:spPr>
+        <p:txBody>
+          <a:bodyPr wrap="square" lIns="0" tIns="0" rIns="0" bIns="0" rtlCol="0" anchor="ctr"/>
+          <a:lstStyle/>
+          <a:p>
+            <a:pPr algn="r" indent="0" marL="0">
+              <a:buNone/>
+            </a:pPr>
+            <a:r>
+              <a:rPr lang="en-US" sz="1200" dirty="0">
+                <a:solidFill>
+                  <a:srgbClr val="9AA3AD"/>
+                </a:solidFill>
+                <a:latin typeface="Inter" pitchFamily="34" charset="0"/>
+                <a:ea typeface="Inter" pitchFamily="34" charset="-122"/>
+                <a:cs typeface="Inter" pitchFamily="34" charset="-120"/>
+              </a:rPr>
+              <a:t>11</a:t>
+            </a:r>
+            <a:endParaRPr lang="en-US" sz="1200" dirty="0"/>
+          </a:p>
+        </p:txBody>
+      </p:sp>
+      <p:sp>
+        <p:nvSpPr>
+          <p:cNvPr id="67" name="Text 65"/>
+          <p:cNvSpPr txBox="1"/>
+          <p:nvPr/>
+        </p:nvSpPr>
+        <p:spPr>
+          <a:xfrm>
+            <a:off x="1014984" y="4358999"/>
+            <a:ext cx="1920240" cy="223759"/>
+          </a:xfrm>
+          <a:prstGeom prst="rect">
+            <a:avLst/>
+          </a:prstGeom>
+          <a:noFill/>
+          <a:ln/>
+        </p:spPr>
+        <p:txBody>
+          <a:bodyPr wrap="square" lIns="0" tIns="0" rIns="0" bIns="0" rtlCol="0" anchor="ctr"/>
+          <a:lstStyle/>
+          <a:p>
+            <a:pPr indent="0" marL="0">
+              <a:buNone/>
+            </a:pPr>
+            <a:r>
+              <a:rPr lang="en-US" sz="1200" dirty="0">
+                <a:solidFill>
+                  <a:srgbClr val="1A1A1A"/>
+                </a:solidFill>
+                <a:latin typeface="Inter" pitchFamily="34" charset="0"/>
+                <a:ea typeface="Inter" pitchFamily="34" charset="-122"/>
+                <a:cs typeface="Inter" pitchFamily="34" charset="-120"/>
+              </a:rPr>
+              <a:t>LEXUS</a:t>
+            </a:r>
+            <a:endParaRPr lang="en-US" sz="1200" dirty="0"/>
+          </a:p>
+        </p:txBody>
+      </p:sp>
+      <p:sp>
+        <p:nvSpPr>
+          <p:cNvPr id="68" name="Shape 66"/>
           <p:cNvSpPr/>
           <p:nvPr/>
         </p:nvSpPr>
         <p:spPr>
           <a:xfrm>
-            <a:off x="5907024" y="4180960"/>
-            <a:ext cx="54864" cy="132319"/>
+            <a:off x="3579876" y="4419414"/>
+            <a:ext cx="83153" cy="102929"/>
           </a:xfrm>
           <a:prstGeom prst="rect">
             <a:avLst/>
@@ -14338,13 +14416,91 @@
       </p:sp>
       <p:sp>
         <p:nvSpPr>
-          <p:cNvPr id="67" name="Text 65"/>
-          <p:cNvSpPr txBox="1"/>
-          <p:nvPr/>
-        </p:nvSpPr>
-        <p:spPr>
-          <a:xfrm>
-            <a:off x="658368" y="4358999"/>
+          <p:cNvPr id="69" name="Text 67"/>
+          <p:cNvSpPr txBox="1"/>
+          <p:nvPr/>
+        </p:nvSpPr>
+        <p:spPr>
+          <a:xfrm>
+            <a:off x="4206240" y="4358999"/>
+            <a:ext cx="777240" cy="223759"/>
+          </a:xfrm>
+          <a:prstGeom prst="rect">
+            <a:avLst/>
+          </a:prstGeom>
+          <a:noFill/>
+          <a:ln/>
+        </p:spPr>
+        <p:txBody>
+          <a:bodyPr wrap="square" lIns="0" tIns="0" rIns="0" bIns="0" rtlCol="0" anchor="ctr"/>
+          <a:lstStyle/>
+          <a:p>
+            <a:pPr algn="r" indent="0" marL="0">
+              <a:buNone/>
+            </a:pPr>
+            <a:r>
+              <a:rPr lang="en-US" sz="1200" b="1" dirty="0">
+                <a:solidFill>
+                  <a:srgbClr val="0B7A4A"/>
+                </a:solidFill>
+                <a:latin typeface="Inter" pitchFamily="34" charset="0"/>
+                <a:ea typeface="Inter" pitchFamily="34" charset="-122"/>
+                <a:cs typeface="Inter" pitchFamily="34" charset="-120"/>
+              </a:rPr>
+              <a:t>+$206K</a:t>
+            </a:r>
+            <a:endParaRPr lang="en-US" sz="1200" dirty="0"/>
+          </a:p>
+        </p:txBody>
+      </p:sp>
+      <p:sp>
+        <p:nvSpPr>
+          <p:cNvPr id="70" name="Text 68"/>
+          <p:cNvSpPr txBox="1"/>
+          <p:nvPr/>
+        </p:nvSpPr>
+        <p:spPr>
+          <a:xfrm>
+            <a:off x="4983480" y="4358999"/>
+            <a:ext cx="868680" cy="223759"/>
+          </a:xfrm>
+          <a:prstGeom prst="rect">
+            <a:avLst/>
+          </a:prstGeom>
+          <a:noFill/>
+          <a:ln/>
+        </p:spPr>
+        <p:txBody>
+          <a:bodyPr wrap="square" lIns="0" tIns="0" rIns="0" bIns="0" rtlCol="0" anchor="ctr"/>
+          <a:lstStyle/>
+          <a:p>
+            <a:pPr algn="r" indent="0" marL="0">
+              <a:buNone/>
+            </a:pPr>
+            <a:r>
+              <a:rPr lang="en-US" sz="1200" dirty="0">
+                <a:solidFill>
+                  <a:srgbClr val="0B7A4A"/>
+                </a:solidFill>
+                <a:latin typeface="Inter" pitchFamily="34" charset="0"/>
+                <a:ea typeface="Inter" pitchFamily="34" charset="-122"/>
+                <a:cs typeface="Inter" pitchFamily="34" charset="-120"/>
+              </a:rPr>
+              <a:t>+20.8%</a:t>
+            </a:r>
+            <a:endParaRPr lang="en-US" sz="1200" dirty="0"/>
+          </a:p>
+        </p:txBody>
+      </p:sp>
+      <p:sp>
+        <p:nvSpPr>
+          <p:cNvPr id="71" name="Text 69"/>
+          <p:cNvSpPr txBox="1"/>
+          <p:nvPr/>
+        </p:nvSpPr>
+        <p:spPr>
+          <a:xfrm>
+            <a:off x="658368" y="4582758"/>
             <a:ext cx="310896" cy="223759"/>
           </a:xfrm>
           <a:prstGeom prst="rect">
@@ -14369,21 +14525,21 @@
                 <a:ea typeface="Inter" pitchFamily="34" charset="-122"/>
                 <a:cs typeface="Inter" pitchFamily="34" charset="-120"/>
               </a:rPr>
-              <a:t>11</a:t>
-            </a:r>
-            <a:endParaRPr lang="en-US" sz="1200" dirty="0"/>
-          </a:p>
-        </p:txBody>
-      </p:sp>
-      <p:sp>
-        <p:nvSpPr>
-          <p:cNvPr id="68" name="Text 66"/>
-          <p:cNvSpPr txBox="1"/>
-          <p:nvPr/>
-        </p:nvSpPr>
-        <p:spPr>
-          <a:xfrm>
-            <a:off x="1014984" y="4358999"/>
+              <a:t>12</a:t>
+            </a:r>
+            <a:endParaRPr lang="en-US" sz="1200" dirty="0"/>
+          </a:p>
+        </p:txBody>
+      </p:sp>
+      <p:sp>
+        <p:nvSpPr>
+          <p:cNvPr id="72" name="Text 70"/>
+          <p:cNvSpPr txBox="1"/>
+          <p:nvPr/>
+        </p:nvSpPr>
+        <p:spPr>
+          <a:xfrm>
+            <a:off x="1014984" y="4582758"/>
             <a:ext cx="1920240" cy="223759"/>
           </a:xfrm>
           <a:prstGeom prst="rect">
@@ -14408,22 +14564,22 @@
                 <a:ea typeface="Inter" pitchFamily="34" charset="-122"/>
                 <a:cs typeface="Inter" pitchFamily="34" charset="-120"/>
               </a:rPr>
-              <a:t>LEXUS</a:t>
-            </a:r>
-            <a:endParaRPr lang="en-US" sz="1200" dirty="0"/>
-          </a:p>
-        </p:txBody>
-      </p:sp>
-      <p:sp>
-        <p:nvSpPr>
-          <p:cNvPr id="69" name="Shape 67"/>
+              <a:t>SUBARU PRESCOTT</a:t>
+            </a:r>
+            <a:endParaRPr lang="en-US" sz="1200" dirty="0"/>
+          </a:p>
+        </p:txBody>
+      </p:sp>
+      <p:sp>
+        <p:nvSpPr>
+          <p:cNvPr id="73" name="Shape 71"/>
           <p:cNvSpPr/>
           <p:nvPr/>
         </p:nvSpPr>
         <p:spPr>
           <a:xfrm>
-            <a:off x="3579876" y="4419414"/>
-            <a:ext cx="83153" cy="102929"/>
+            <a:off x="3579876" y="4643173"/>
+            <a:ext cx="73936" cy="102929"/>
           </a:xfrm>
           <a:prstGeom prst="rect">
             <a:avLst/>
@@ -14436,13 +14592,13 @@
       </p:sp>
       <p:sp>
         <p:nvSpPr>
-          <p:cNvPr id="70" name="Text 68"/>
-          <p:cNvSpPr txBox="1"/>
-          <p:nvPr/>
-        </p:nvSpPr>
-        <p:spPr>
-          <a:xfrm>
-            <a:off x="4206240" y="4358999"/>
+          <p:cNvPr id="74" name="Text 72"/>
+          <p:cNvSpPr txBox="1"/>
+          <p:nvPr/>
+        </p:nvSpPr>
+        <p:spPr>
+          <a:xfrm>
+            <a:off x="4206240" y="4582758"/>
             <a:ext cx="777240" cy="223759"/>
           </a:xfrm>
           <a:prstGeom prst="rect">
@@ -14467,21 +14623,21 @@
                 <a:ea typeface="Inter" pitchFamily="34" charset="-122"/>
                 <a:cs typeface="Inter" pitchFamily="34" charset="-120"/>
               </a:rPr>
-              <a:t>+$206K</a:t>
-            </a:r>
-            <a:endParaRPr lang="en-US" sz="1200" dirty="0"/>
-          </a:p>
-        </p:txBody>
-      </p:sp>
-      <p:sp>
-        <p:nvSpPr>
-          <p:cNvPr id="71" name="Text 69"/>
-          <p:cNvSpPr txBox="1"/>
-          <p:nvPr/>
-        </p:nvSpPr>
-        <p:spPr>
-          <a:xfrm>
-            <a:off x="4983480" y="4358999"/>
+              <a:t>+$183K</a:t>
+            </a:r>
+            <a:endParaRPr lang="en-US" sz="1200" dirty="0"/>
+          </a:p>
+        </p:txBody>
+      </p:sp>
+      <p:sp>
+        <p:nvSpPr>
+          <p:cNvPr id="75" name="Text 73"/>
+          <p:cNvSpPr txBox="1"/>
+          <p:nvPr/>
+        </p:nvSpPr>
+        <p:spPr>
+          <a:xfrm>
+            <a:off x="4983480" y="4582758"/>
             <a:ext cx="868680" cy="223759"/>
           </a:xfrm>
           <a:prstGeom prst="rect">
@@ -14506,100 +14662,22 @@
                 <a:ea typeface="Inter" pitchFamily="34" charset="-122"/>
                 <a:cs typeface="Inter" pitchFamily="34" charset="-120"/>
               </a:rPr>
-              <a:t>+20.8%</a:t>
-            </a:r>
-            <a:endParaRPr lang="en-US" sz="1200" dirty="0"/>
-          </a:p>
-        </p:txBody>
-      </p:sp>
-      <p:sp>
-        <p:nvSpPr>
-          <p:cNvPr id="72" name="Text 70"/>
-          <p:cNvSpPr txBox="1"/>
-          <p:nvPr/>
-        </p:nvSpPr>
-        <p:spPr>
-          <a:xfrm>
-            <a:off x="658368" y="4582758"/>
-            <a:ext cx="310896" cy="223759"/>
-          </a:xfrm>
-          <a:prstGeom prst="rect">
-            <a:avLst/>
-          </a:prstGeom>
-          <a:noFill/>
-          <a:ln/>
-        </p:spPr>
-        <p:txBody>
-          <a:bodyPr wrap="square" lIns="0" tIns="0" rIns="0" bIns="0" rtlCol="0" anchor="ctr"/>
-          <a:lstStyle/>
-          <a:p>
-            <a:pPr algn="r" indent="0" marL="0">
-              <a:buNone/>
-            </a:pPr>
-            <a:r>
-              <a:rPr lang="en-US" sz="1200" dirty="0">
-                <a:solidFill>
-                  <a:srgbClr val="9AA3AD"/>
-                </a:solidFill>
-                <a:latin typeface="Inter" pitchFamily="34" charset="0"/>
-                <a:ea typeface="Inter" pitchFamily="34" charset="-122"/>
-                <a:cs typeface="Inter" pitchFamily="34" charset="-120"/>
-              </a:rPr>
-              <a:t>12</a:t>
-            </a:r>
-            <a:endParaRPr lang="en-US" sz="1200" dirty="0"/>
-          </a:p>
-        </p:txBody>
-      </p:sp>
-      <p:sp>
-        <p:nvSpPr>
-          <p:cNvPr id="73" name="Text 71"/>
-          <p:cNvSpPr txBox="1"/>
-          <p:nvPr/>
-        </p:nvSpPr>
-        <p:spPr>
-          <a:xfrm>
-            <a:off x="1014984" y="4582758"/>
-            <a:ext cx="1920240" cy="223759"/>
-          </a:xfrm>
-          <a:prstGeom prst="rect">
-            <a:avLst/>
-          </a:prstGeom>
-          <a:noFill/>
-          <a:ln/>
-        </p:spPr>
-        <p:txBody>
-          <a:bodyPr wrap="square" lIns="0" tIns="0" rIns="0" bIns="0" rtlCol="0" anchor="ctr"/>
-          <a:lstStyle/>
-          <a:p>
-            <a:pPr indent="0" marL="0">
-              <a:buNone/>
-            </a:pPr>
-            <a:r>
-              <a:rPr lang="en-US" sz="1200" dirty="0">
-                <a:solidFill>
-                  <a:srgbClr val="1A1A1A"/>
-                </a:solidFill>
-                <a:latin typeface="Inter" pitchFamily="34" charset="0"/>
-                <a:ea typeface="Inter" pitchFamily="34" charset="-122"/>
-                <a:cs typeface="Inter" pitchFamily="34" charset="-120"/>
-              </a:rPr>
-              <a:t>SUBARU PRESCOTT</a:t>
-            </a:r>
-            <a:endParaRPr lang="en-US" sz="1200" dirty="0"/>
-          </a:p>
-        </p:txBody>
-      </p:sp>
-      <p:sp>
-        <p:nvSpPr>
-          <p:cNvPr id="74" name="Shape 72"/>
+              <a:t>+335.3%</a:t>
+            </a:r>
+            <a:endParaRPr lang="en-US" sz="1200" dirty="0"/>
+          </a:p>
+        </p:txBody>
+      </p:sp>
+      <p:sp>
+        <p:nvSpPr>
+          <p:cNvPr id="76" name="Shape 74"/>
           <p:cNvSpPr/>
           <p:nvPr/>
         </p:nvSpPr>
         <p:spPr>
           <a:xfrm>
-            <a:off x="3579876" y="4643173"/>
-            <a:ext cx="73936" cy="102929"/>
+            <a:off x="5907024" y="4628478"/>
+            <a:ext cx="54864" cy="132319"/>
           </a:xfrm>
           <a:prstGeom prst="rect">
             <a:avLst/>
@@ -14612,84 +14690,6 @@
       </p:sp>
       <p:sp>
         <p:nvSpPr>
-          <p:cNvPr id="75" name="Text 73"/>
-          <p:cNvSpPr txBox="1"/>
-          <p:nvPr/>
-        </p:nvSpPr>
-        <p:spPr>
-          <a:xfrm>
-            <a:off x="4206240" y="4582758"/>
-            <a:ext cx="777240" cy="223759"/>
-          </a:xfrm>
-          <a:prstGeom prst="rect">
-            <a:avLst/>
-          </a:prstGeom>
-          <a:noFill/>
-          <a:ln/>
-        </p:spPr>
-        <p:txBody>
-          <a:bodyPr wrap="square" lIns="0" tIns="0" rIns="0" bIns="0" rtlCol="0" anchor="ctr"/>
-          <a:lstStyle/>
-          <a:p>
-            <a:pPr algn="r" indent="0" marL="0">
-              <a:buNone/>
-            </a:pPr>
-            <a:r>
-              <a:rPr lang="en-US" sz="1200" b="1" dirty="0">
-                <a:solidFill>
-                  <a:srgbClr val="0B7A4A"/>
-                </a:solidFill>
-                <a:latin typeface="Inter" pitchFamily="34" charset="0"/>
-                <a:ea typeface="Inter" pitchFamily="34" charset="-122"/>
-                <a:cs typeface="Inter" pitchFamily="34" charset="-120"/>
-              </a:rPr>
-              <a:t>+$183K</a:t>
-            </a:r>
-            <a:endParaRPr lang="en-US" sz="1200" dirty="0"/>
-          </a:p>
-        </p:txBody>
-      </p:sp>
-      <p:sp>
-        <p:nvSpPr>
-          <p:cNvPr id="76" name="Text 74"/>
-          <p:cNvSpPr txBox="1"/>
-          <p:nvPr/>
-        </p:nvSpPr>
-        <p:spPr>
-          <a:xfrm>
-            <a:off x="4983480" y="4582758"/>
-            <a:ext cx="868680" cy="223759"/>
-          </a:xfrm>
-          <a:prstGeom prst="rect">
-            <a:avLst/>
-          </a:prstGeom>
-          <a:noFill/>
-          <a:ln/>
-        </p:spPr>
-        <p:txBody>
-          <a:bodyPr wrap="square" lIns="0" tIns="0" rIns="0" bIns="0" rtlCol="0" anchor="ctr"/>
-          <a:lstStyle/>
-          <a:p>
-            <a:pPr algn="r" indent="0" marL="0">
-              <a:buNone/>
-            </a:pPr>
-            <a:r>
-              <a:rPr lang="en-US" sz="1200" dirty="0">
-                <a:solidFill>
-                  <a:srgbClr val="0B7A4A"/>
-                </a:solidFill>
-                <a:latin typeface="Inter" pitchFamily="34" charset="0"/>
-                <a:ea typeface="Inter" pitchFamily="34" charset="-122"/>
-                <a:cs typeface="Inter" pitchFamily="34" charset="-120"/>
-              </a:rPr>
-              <a:t>n/m</a:t>
-            </a:r>
-            <a:endParaRPr lang="en-US" sz="1200" dirty="0"/>
-          </a:p>
-        </p:txBody>
-      </p:sp>
-      <p:sp>
-        <p:nvSpPr>
           <p:cNvPr id="77" name="Text 75"/>
           <p:cNvSpPr txBox="1"/>
           <p:nvPr/>
@@ -15210,7 +15210,7 @@
                 <a:ea typeface="Inter" pitchFamily="34" charset="-122"/>
                 <a:cs typeface="Inter" pitchFamily="34" charset="-120"/>
               </a:rPr>
-              <a:t>n/m</a:t>
+              <a:t>+115.7%</a:t>
             </a:r>
             <a:endParaRPr lang="en-US" sz="1200" dirty="0"/>
           </a:p>
@@ -16090,7 +16090,7 @@
                 <a:ea typeface="Inter" pitchFamily="34" charset="-122"/>
                 <a:cs typeface="Inter" pitchFamily="34" charset="-120"/>
               </a:rPr>
-              <a:t>n/m</a:t>
+              <a:t>+41.3%</a:t>
             </a:r>
             <a:endParaRPr lang="en-US" sz="1200" dirty="0"/>
           </a:p>

</xml_diff>

<commit_message>
Preview: shade stores whose fixed ops net profit crossed zero
Co-Authored-By: Claude Opus 5.5 <noreply@anthropic.com>
Claude-Session: https://claude.ai/code/session_01Xa4nFVxuQGXmHARGph9WhS
</commit_message>
<xml_diff>
--- a/day2-deck/decks/Fixed Absorption & Net Profit - Preview.pptx
+++ b/day2-deck/decks/Fixed Absorption & Net Profit - Preview.pptx
@@ -2817,7 +2817,7 @@
           <a:p>
             <a:r>
               <a:rPr lang="en-US" dirty="0"/>
-              <a:t>Source: Qlik - Profit &amp; Loss, Detail statement. Same-store, INEOS excluded (opened 2026). Fixed ops net profit = service (Mechanical) + parts (P&amp;A) department profit: department gross less the department's own expenses; GMC Prescott body shop is its own department and is not included. Ranked by dollar change, Jan-Sep 2026 vs Jan-Sep 2025; percent change alongside, top three and bottom three by percent marked. Percent change = dollar change / 2025 profit; where 2025 was a loss, divided by the size of the loss, so an improvement reads as positive.</a:t>
+              <a:t>Source: Qlik - Profit &amp; Loss, Detail statement. Same-store, INEOS excluded (opened 2026). Fixed ops net profit = service (Mechanical) + parts (P&amp;A) department profit: department gross less the department's own expenses; GMC Prescott body shop is its own department and is not included. Ranked by dollar change, Jan-Sep 2026 vs Jan-Sep 2025; percent change alongside, top three and bottom three by percent marked. Percent change = dollar change / 2025 profit; where 2025 was a loss, divided by the size of the loss, so an improvement reads as positive.Green band: lost money in fixed ops in 2025, made money in 2026 (Lincoln −$389K to $94K, Subaru Prescott −$55K to $129K and GMC Prescott −$125K to $20K). Red band: made money in 2025, lost money in 2026 (VW St George $153K to −$59K).</a:t>
             </a:r>
             <a:endParaRPr lang="en-US" dirty="0"/>
           </a:p>
@@ -13242,7 +13242,27 @@
       </p:sp>
       <p:sp>
         <p:nvSpPr>
-          <p:cNvPr id="35" name="Text 33"/>
+          <p:cNvPr id="35" name="Shape 33"/>
+          <p:cNvSpPr/>
+          <p:nvPr/>
+        </p:nvSpPr>
+        <p:spPr>
+          <a:xfrm>
+            <a:off x="612648" y="3025588"/>
+            <a:ext cx="5138928" cy="205471"/>
+          </a:xfrm>
+          <a:prstGeom prst="rect">
+            <a:avLst/>
+          </a:prstGeom>
+          <a:solidFill>
+            <a:srgbClr val="E6F6EE"/>
+          </a:solidFill>
+          <a:ln/>
+        </p:spPr>
+      </p:sp>
+      <p:sp>
+        <p:nvSpPr>
+          <p:cNvPr id="36" name="Text 34"/>
           <p:cNvSpPr txBox="1"/>
           <p:nvPr/>
         </p:nvSpPr>
@@ -13281,7 +13301,7 @@
       </p:sp>
       <p:sp>
         <p:nvSpPr>
-          <p:cNvPr id="36" name="Text 34"/>
+          <p:cNvPr id="37" name="Text 35"/>
           <p:cNvSpPr txBox="1"/>
           <p:nvPr/>
         </p:nvSpPr>
@@ -13320,7 +13340,7 @@
       </p:sp>
       <p:sp>
         <p:nvSpPr>
-          <p:cNvPr id="37" name="Shape 35"/>
+          <p:cNvPr id="38" name="Shape 36"/>
           <p:cNvSpPr/>
           <p:nvPr/>
         </p:nvSpPr>
@@ -13340,7 +13360,7 @@
       </p:sp>
       <p:sp>
         <p:nvSpPr>
-          <p:cNvPr id="38" name="Text 36"/>
+          <p:cNvPr id="39" name="Text 37"/>
           <p:cNvSpPr txBox="1"/>
           <p:nvPr/>
         </p:nvSpPr>
@@ -13379,7 +13399,7 @@
       </p:sp>
       <p:sp>
         <p:nvSpPr>
-          <p:cNvPr id="39" name="Text 37"/>
+          <p:cNvPr id="40" name="Text 38"/>
           <p:cNvSpPr txBox="1"/>
           <p:nvPr/>
         </p:nvSpPr>
@@ -13418,7 +13438,7 @@
       </p:sp>
       <p:sp>
         <p:nvSpPr>
-          <p:cNvPr id="40" name="Text 38"/>
+          <p:cNvPr id="41" name="Text 39"/>
           <p:cNvSpPr txBox="1"/>
           <p:nvPr/>
         </p:nvSpPr>
@@ -13457,7 +13477,7 @@
       </p:sp>
       <p:sp>
         <p:nvSpPr>
-          <p:cNvPr id="41" name="Text 39"/>
+          <p:cNvPr id="42" name="Text 40"/>
           <p:cNvSpPr txBox="1"/>
           <p:nvPr/>
         </p:nvSpPr>
@@ -13496,7 +13516,7 @@
       </p:sp>
       <p:sp>
         <p:nvSpPr>
-          <p:cNvPr id="42" name="Shape 40"/>
+          <p:cNvPr id="43" name="Shape 41"/>
           <p:cNvSpPr/>
           <p:nvPr/>
         </p:nvSpPr>
@@ -13516,7 +13536,7 @@
       </p:sp>
       <p:sp>
         <p:nvSpPr>
-          <p:cNvPr id="43" name="Text 41"/>
+          <p:cNvPr id="44" name="Text 42"/>
           <p:cNvSpPr txBox="1"/>
           <p:nvPr/>
         </p:nvSpPr>
@@ -13555,7 +13575,7 @@
       </p:sp>
       <p:sp>
         <p:nvSpPr>
-          <p:cNvPr id="44" name="Text 42"/>
+          <p:cNvPr id="45" name="Text 43"/>
           <p:cNvSpPr txBox="1"/>
           <p:nvPr/>
         </p:nvSpPr>
@@ -13594,7 +13614,7 @@
       </p:sp>
       <p:sp>
         <p:nvSpPr>
-          <p:cNvPr id="45" name="Text 43"/>
+          <p:cNvPr id="46" name="Text 44"/>
           <p:cNvSpPr txBox="1"/>
           <p:nvPr/>
         </p:nvSpPr>
@@ -13633,7 +13653,7 @@
       </p:sp>
       <p:sp>
         <p:nvSpPr>
-          <p:cNvPr id="46" name="Text 44"/>
+          <p:cNvPr id="47" name="Text 45"/>
           <p:cNvSpPr txBox="1"/>
           <p:nvPr/>
         </p:nvSpPr>
@@ -13672,7 +13692,7 @@
       </p:sp>
       <p:sp>
         <p:nvSpPr>
-          <p:cNvPr id="47" name="Shape 45"/>
+          <p:cNvPr id="48" name="Shape 46"/>
           <p:cNvSpPr/>
           <p:nvPr/>
         </p:nvSpPr>
@@ -13692,7 +13712,7 @@
       </p:sp>
       <p:sp>
         <p:nvSpPr>
-          <p:cNvPr id="48" name="Text 46"/>
+          <p:cNvPr id="49" name="Text 47"/>
           <p:cNvSpPr txBox="1"/>
           <p:nvPr/>
         </p:nvSpPr>
@@ -13731,7 +13751,7 @@
       </p:sp>
       <p:sp>
         <p:nvSpPr>
-          <p:cNvPr id="49" name="Text 47"/>
+          <p:cNvPr id="50" name="Text 48"/>
           <p:cNvSpPr txBox="1"/>
           <p:nvPr/>
         </p:nvSpPr>
@@ -13770,7 +13790,7 @@
       </p:sp>
       <p:sp>
         <p:nvSpPr>
-          <p:cNvPr id="50" name="Text 48"/>
+          <p:cNvPr id="51" name="Text 49"/>
           <p:cNvSpPr txBox="1"/>
           <p:nvPr/>
         </p:nvSpPr>
@@ -13809,7 +13829,7 @@
       </p:sp>
       <p:sp>
         <p:nvSpPr>
-          <p:cNvPr id="51" name="Text 49"/>
+          <p:cNvPr id="52" name="Text 50"/>
           <p:cNvSpPr txBox="1"/>
           <p:nvPr/>
         </p:nvSpPr>
@@ -13848,7 +13868,7 @@
       </p:sp>
       <p:sp>
         <p:nvSpPr>
-          <p:cNvPr id="52" name="Shape 50"/>
+          <p:cNvPr id="53" name="Shape 51"/>
           <p:cNvSpPr/>
           <p:nvPr/>
         </p:nvSpPr>
@@ -13868,7 +13888,7 @@
       </p:sp>
       <p:sp>
         <p:nvSpPr>
-          <p:cNvPr id="53" name="Text 51"/>
+          <p:cNvPr id="54" name="Text 52"/>
           <p:cNvSpPr txBox="1"/>
           <p:nvPr/>
         </p:nvSpPr>
@@ -13907,7 +13927,7 @@
       </p:sp>
       <p:sp>
         <p:nvSpPr>
-          <p:cNvPr id="54" name="Text 52"/>
+          <p:cNvPr id="55" name="Text 53"/>
           <p:cNvSpPr txBox="1"/>
           <p:nvPr/>
         </p:nvSpPr>
@@ -13946,7 +13966,7 @@
       </p:sp>
       <p:sp>
         <p:nvSpPr>
-          <p:cNvPr id="55" name="Shape 53"/>
+          <p:cNvPr id="56" name="Shape 54"/>
           <p:cNvSpPr/>
           <p:nvPr/>
         </p:nvSpPr>
@@ -13966,7 +13986,7 @@
       </p:sp>
       <p:sp>
         <p:nvSpPr>
-          <p:cNvPr id="56" name="Text 54"/>
+          <p:cNvPr id="57" name="Text 55"/>
           <p:cNvSpPr txBox="1"/>
           <p:nvPr/>
         </p:nvSpPr>
@@ -14005,7 +14025,7 @@
       </p:sp>
       <p:sp>
         <p:nvSpPr>
-          <p:cNvPr id="57" name="Text 55"/>
+          <p:cNvPr id="58" name="Text 56"/>
           <p:cNvSpPr txBox="1"/>
           <p:nvPr/>
         </p:nvSpPr>
@@ -14044,7 +14064,7 @@
       </p:sp>
       <p:sp>
         <p:nvSpPr>
-          <p:cNvPr id="58" name="Shape 56"/>
+          <p:cNvPr id="59" name="Shape 57"/>
           <p:cNvSpPr/>
           <p:nvPr/>
         </p:nvSpPr>
@@ -14064,7 +14084,7 @@
       </p:sp>
       <p:sp>
         <p:nvSpPr>
-          <p:cNvPr id="59" name="Text 57"/>
+          <p:cNvPr id="60" name="Text 58"/>
           <p:cNvSpPr txBox="1"/>
           <p:nvPr/>
         </p:nvSpPr>
@@ -14103,7 +14123,7 @@
       </p:sp>
       <p:sp>
         <p:nvSpPr>
-          <p:cNvPr id="60" name="Text 58"/>
+          <p:cNvPr id="61" name="Text 59"/>
           <p:cNvSpPr txBox="1"/>
           <p:nvPr/>
         </p:nvSpPr>
@@ -14142,7 +14162,7 @@
       </p:sp>
       <p:sp>
         <p:nvSpPr>
-          <p:cNvPr id="61" name="Text 59"/>
+          <p:cNvPr id="62" name="Text 60"/>
           <p:cNvSpPr txBox="1"/>
           <p:nvPr/>
         </p:nvSpPr>
@@ -14181,7 +14201,7 @@
       </p:sp>
       <p:sp>
         <p:nvSpPr>
-          <p:cNvPr id="62" name="Text 60"/>
+          <p:cNvPr id="63" name="Text 61"/>
           <p:cNvSpPr txBox="1"/>
           <p:nvPr/>
         </p:nvSpPr>
@@ -14220,7 +14240,7 @@
       </p:sp>
       <p:sp>
         <p:nvSpPr>
-          <p:cNvPr id="63" name="Shape 61"/>
+          <p:cNvPr id="64" name="Shape 62"/>
           <p:cNvSpPr/>
           <p:nvPr/>
         </p:nvSpPr>
@@ -14240,7 +14260,7 @@
       </p:sp>
       <p:sp>
         <p:nvSpPr>
-          <p:cNvPr id="64" name="Text 62"/>
+          <p:cNvPr id="65" name="Text 63"/>
           <p:cNvSpPr txBox="1"/>
           <p:nvPr/>
         </p:nvSpPr>
@@ -14279,7 +14299,7 @@
       </p:sp>
       <p:sp>
         <p:nvSpPr>
-          <p:cNvPr id="65" name="Text 63"/>
+          <p:cNvPr id="66" name="Text 64"/>
           <p:cNvSpPr txBox="1"/>
           <p:nvPr/>
         </p:nvSpPr>
@@ -14318,7 +14338,7 @@
       </p:sp>
       <p:sp>
         <p:nvSpPr>
-          <p:cNvPr id="66" name="Text 64"/>
+          <p:cNvPr id="67" name="Text 65"/>
           <p:cNvSpPr txBox="1"/>
           <p:nvPr/>
         </p:nvSpPr>
@@ -14357,7 +14377,7 @@
       </p:sp>
       <p:sp>
         <p:nvSpPr>
-          <p:cNvPr id="67" name="Text 65"/>
+          <p:cNvPr id="68" name="Text 66"/>
           <p:cNvSpPr txBox="1"/>
           <p:nvPr/>
         </p:nvSpPr>
@@ -14396,7 +14416,7 @@
       </p:sp>
       <p:sp>
         <p:nvSpPr>
-          <p:cNvPr id="68" name="Shape 66"/>
+          <p:cNvPr id="69" name="Shape 67"/>
           <p:cNvSpPr/>
           <p:nvPr/>
         </p:nvSpPr>
@@ -14416,7 +14436,7 @@
       </p:sp>
       <p:sp>
         <p:nvSpPr>
-          <p:cNvPr id="69" name="Text 67"/>
+          <p:cNvPr id="70" name="Text 68"/>
           <p:cNvSpPr txBox="1"/>
           <p:nvPr/>
         </p:nvSpPr>
@@ -14455,7 +14475,7 @@
       </p:sp>
       <p:sp>
         <p:nvSpPr>
-          <p:cNvPr id="70" name="Text 68"/>
+          <p:cNvPr id="71" name="Text 69"/>
           <p:cNvSpPr txBox="1"/>
           <p:nvPr/>
         </p:nvSpPr>
@@ -14494,7 +14514,27 @@
       </p:sp>
       <p:sp>
         <p:nvSpPr>
-          <p:cNvPr id="71" name="Text 69"/>
+          <p:cNvPr id="72" name="Shape 70"/>
+          <p:cNvSpPr/>
+          <p:nvPr/>
+        </p:nvSpPr>
+        <p:spPr>
+          <a:xfrm>
+            <a:off x="612648" y="4591902"/>
+            <a:ext cx="5138928" cy="205471"/>
+          </a:xfrm>
+          <a:prstGeom prst="rect">
+            <a:avLst/>
+          </a:prstGeom>
+          <a:solidFill>
+            <a:srgbClr val="E6F6EE"/>
+          </a:solidFill>
+          <a:ln/>
+        </p:spPr>
+      </p:sp>
+      <p:sp>
+        <p:nvSpPr>
+          <p:cNvPr id="73" name="Text 71"/>
           <p:cNvSpPr txBox="1"/>
           <p:nvPr/>
         </p:nvSpPr>
@@ -14533,7 +14573,7 @@
       </p:sp>
       <p:sp>
         <p:nvSpPr>
-          <p:cNvPr id="72" name="Text 70"/>
+          <p:cNvPr id="74" name="Text 72"/>
           <p:cNvSpPr txBox="1"/>
           <p:nvPr/>
         </p:nvSpPr>
@@ -14572,7 +14612,7 @@
       </p:sp>
       <p:sp>
         <p:nvSpPr>
-          <p:cNvPr id="73" name="Shape 71"/>
+          <p:cNvPr id="75" name="Shape 73"/>
           <p:cNvSpPr/>
           <p:nvPr/>
         </p:nvSpPr>
@@ -14592,7 +14632,7 @@
       </p:sp>
       <p:sp>
         <p:nvSpPr>
-          <p:cNvPr id="74" name="Text 72"/>
+          <p:cNvPr id="76" name="Text 74"/>
           <p:cNvSpPr txBox="1"/>
           <p:nvPr/>
         </p:nvSpPr>
@@ -14631,7 +14671,7 @@
       </p:sp>
       <p:sp>
         <p:nvSpPr>
-          <p:cNvPr id="75" name="Text 73"/>
+          <p:cNvPr id="77" name="Text 75"/>
           <p:cNvSpPr txBox="1"/>
           <p:nvPr/>
         </p:nvSpPr>
@@ -14670,7 +14710,7 @@
       </p:sp>
       <p:sp>
         <p:nvSpPr>
-          <p:cNvPr id="76" name="Shape 74"/>
+          <p:cNvPr id="78" name="Shape 76"/>
           <p:cNvSpPr/>
           <p:nvPr/>
         </p:nvSpPr>
@@ -14690,7 +14730,7 @@
       </p:sp>
       <p:sp>
         <p:nvSpPr>
-          <p:cNvPr id="77" name="Text 75"/>
+          <p:cNvPr id="79" name="Text 77"/>
           <p:cNvSpPr txBox="1"/>
           <p:nvPr/>
         </p:nvSpPr>
@@ -14729,7 +14769,7 @@
       </p:sp>
       <p:sp>
         <p:nvSpPr>
-          <p:cNvPr id="78" name="Text 76"/>
+          <p:cNvPr id="80" name="Text 78"/>
           <p:cNvSpPr txBox="1"/>
           <p:nvPr/>
         </p:nvSpPr>
@@ -14768,7 +14808,7 @@
       </p:sp>
       <p:sp>
         <p:nvSpPr>
-          <p:cNvPr id="79" name="Shape 77"/>
+          <p:cNvPr id="81" name="Shape 79"/>
           <p:cNvSpPr/>
           <p:nvPr/>
         </p:nvSpPr>
@@ -14788,7 +14828,7 @@
       </p:sp>
       <p:sp>
         <p:nvSpPr>
-          <p:cNvPr id="80" name="Text 78"/>
+          <p:cNvPr id="82" name="Text 80"/>
           <p:cNvSpPr txBox="1"/>
           <p:nvPr/>
         </p:nvSpPr>
@@ -14827,7 +14867,7 @@
       </p:sp>
       <p:sp>
         <p:nvSpPr>
-          <p:cNvPr id="81" name="Text 79"/>
+          <p:cNvPr id="83" name="Text 81"/>
           <p:cNvSpPr txBox="1"/>
           <p:nvPr/>
         </p:nvSpPr>
@@ -14866,7 +14906,7 @@
       </p:sp>
       <p:sp>
         <p:nvSpPr>
-          <p:cNvPr id="82" name="Text 80"/>
+          <p:cNvPr id="84" name="Text 82"/>
           <p:cNvSpPr txBox="1"/>
           <p:nvPr/>
         </p:nvSpPr>
@@ -14905,7 +14945,7 @@
       </p:sp>
       <p:sp>
         <p:nvSpPr>
-          <p:cNvPr id="83" name="Text 81"/>
+          <p:cNvPr id="85" name="Text 83"/>
           <p:cNvSpPr txBox="1"/>
           <p:nvPr/>
         </p:nvSpPr>
@@ -14944,7 +14984,7 @@
       </p:sp>
       <p:sp>
         <p:nvSpPr>
-          <p:cNvPr id="84" name="Shape 82"/>
+          <p:cNvPr id="86" name="Shape 84"/>
           <p:cNvSpPr/>
           <p:nvPr/>
         </p:nvSpPr>
@@ -14964,7 +15004,7 @@
       </p:sp>
       <p:sp>
         <p:nvSpPr>
-          <p:cNvPr id="85" name="Text 83"/>
+          <p:cNvPr id="87" name="Text 85"/>
           <p:cNvSpPr txBox="1"/>
           <p:nvPr/>
         </p:nvSpPr>
@@ -15003,7 +15043,7 @@
       </p:sp>
       <p:sp>
         <p:nvSpPr>
-          <p:cNvPr id="86" name="Text 84"/>
+          <p:cNvPr id="88" name="Text 86"/>
           <p:cNvSpPr txBox="1"/>
           <p:nvPr/>
         </p:nvSpPr>
@@ -15042,7 +15082,27 @@
       </p:sp>
       <p:sp>
         <p:nvSpPr>
-          <p:cNvPr id="87" name="Text 85"/>
+          <p:cNvPr id="89" name="Shape 87"/>
+          <p:cNvSpPr/>
+          <p:nvPr/>
+        </p:nvSpPr>
+        <p:spPr>
+          <a:xfrm>
+            <a:off x="612648" y="5263179"/>
+            <a:ext cx="5138928" cy="205471"/>
+          </a:xfrm>
+          <a:prstGeom prst="rect">
+            <a:avLst/>
+          </a:prstGeom>
+          <a:solidFill>
+            <a:srgbClr val="E6F6EE"/>
+          </a:solidFill>
+          <a:ln/>
+        </p:spPr>
+      </p:sp>
+      <p:sp>
+        <p:nvSpPr>
+          <p:cNvPr id="90" name="Text 88"/>
           <p:cNvSpPr txBox="1"/>
           <p:nvPr/>
         </p:nvSpPr>
@@ -15081,7 +15141,7 @@
       </p:sp>
       <p:sp>
         <p:nvSpPr>
-          <p:cNvPr id="88" name="Text 86"/>
+          <p:cNvPr id="91" name="Text 89"/>
           <p:cNvSpPr txBox="1"/>
           <p:nvPr/>
         </p:nvSpPr>
@@ -15120,7 +15180,7 @@
       </p:sp>
       <p:sp>
         <p:nvSpPr>
-          <p:cNvPr id="89" name="Shape 87"/>
+          <p:cNvPr id="92" name="Shape 90"/>
           <p:cNvSpPr/>
           <p:nvPr/>
         </p:nvSpPr>
@@ -15140,7 +15200,7 @@
       </p:sp>
       <p:sp>
         <p:nvSpPr>
-          <p:cNvPr id="90" name="Text 88"/>
+          <p:cNvPr id="93" name="Text 91"/>
           <p:cNvSpPr txBox="1"/>
           <p:nvPr/>
         </p:nvSpPr>
@@ -15179,7 +15239,7 @@
       </p:sp>
       <p:sp>
         <p:nvSpPr>
-          <p:cNvPr id="91" name="Text 89"/>
+          <p:cNvPr id="94" name="Text 92"/>
           <p:cNvSpPr txBox="1"/>
           <p:nvPr/>
         </p:nvSpPr>
@@ -15218,7 +15278,7 @@
       </p:sp>
       <p:sp>
         <p:nvSpPr>
-          <p:cNvPr id="92" name="Text 90"/>
+          <p:cNvPr id="95" name="Text 93"/>
           <p:cNvSpPr txBox="1"/>
           <p:nvPr/>
         </p:nvSpPr>
@@ -15257,7 +15317,7 @@
       </p:sp>
       <p:sp>
         <p:nvSpPr>
-          <p:cNvPr id="93" name="Text 91"/>
+          <p:cNvPr id="96" name="Text 94"/>
           <p:cNvSpPr txBox="1"/>
           <p:nvPr/>
         </p:nvSpPr>
@@ -15296,7 +15356,7 @@
       </p:sp>
       <p:sp>
         <p:nvSpPr>
-          <p:cNvPr id="94" name="Shape 92"/>
+          <p:cNvPr id="97" name="Shape 95"/>
           <p:cNvSpPr/>
           <p:nvPr/>
         </p:nvSpPr>
@@ -15316,7 +15376,7 @@
       </p:sp>
       <p:sp>
         <p:nvSpPr>
-          <p:cNvPr id="95" name="Text 93"/>
+          <p:cNvPr id="98" name="Text 96"/>
           <p:cNvSpPr txBox="1"/>
           <p:nvPr/>
         </p:nvSpPr>
@@ -15355,7 +15415,7 @@
       </p:sp>
       <p:sp>
         <p:nvSpPr>
-          <p:cNvPr id="96" name="Text 94"/>
+          <p:cNvPr id="99" name="Text 97"/>
           <p:cNvSpPr txBox="1"/>
           <p:nvPr/>
         </p:nvSpPr>
@@ -15394,7 +15454,7 @@
       </p:sp>
       <p:sp>
         <p:nvSpPr>
-          <p:cNvPr id="97" name="Text 95"/>
+          <p:cNvPr id="100" name="Text 98"/>
           <p:cNvSpPr txBox="1"/>
           <p:nvPr/>
         </p:nvSpPr>
@@ -15433,7 +15493,7 @@
       </p:sp>
       <p:sp>
         <p:nvSpPr>
-          <p:cNvPr id="98" name="Text 96"/>
+          <p:cNvPr id="101" name="Text 99"/>
           <p:cNvSpPr txBox="1"/>
           <p:nvPr/>
         </p:nvSpPr>
@@ -15472,7 +15532,7 @@
       </p:sp>
       <p:sp>
         <p:nvSpPr>
-          <p:cNvPr id="99" name="Shape 97"/>
+          <p:cNvPr id="102" name="Shape 100"/>
           <p:cNvSpPr/>
           <p:nvPr/>
         </p:nvSpPr>
@@ -15492,7 +15552,7 @@
       </p:sp>
       <p:sp>
         <p:nvSpPr>
-          <p:cNvPr id="100" name="Text 98"/>
+          <p:cNvPr id="103" name="Text 101"/>
           <p:cNvSpPr txBox="1"/>
           <p:nvPr/>
         </p:nvSpPr>
@@ -15531,7 +15591,7 @@
       </p:sp>
       <p:sp>
         <p:nvSpPr>
-          <p:cNvPr id="101" name="Text 99"/>
+          <p:cNvPr id="104" name="Text 102"/>
           <p:cNvSpPr txBox="1"/>
           <p:nvPr/>
         </p:nvSpPr>
@@ -15570,7 +15630,7 @@
       </p:sp>
       <p:sp>
         <p:nvSpPr>
-          <p:cNvPr id="102" name="Text 100"/>
+          <p:cNvPr id="105" name="Text 103"/>
           <p:cNvSpPr txBox="1"/>
           <p:nvPr/>
         </p:nvSpPr>
@@ -15609,7 +15669,7 @@
       </p:sp>
       <p:sp>
         <p:nvSpPr>
-          <p:cNvPr id="103" name="Text 101"/>
+          <p:cNvPr id="106" name="Text 104"/>
           <p:cNvSpPr txBox="1"/>
           <p:nvPr/>
         </p:nvSpPr>
@@ -15648,7 +15708,7 @@
       </p:sp>
       <p:sp>
         <p:nvSpPr>
-          <p:cNvPr id="104" name="Shape 102"/>
+          <p:cNvPr id="107" name="Shape 105"/>
           <p:cNvSpPr/>
           <p:nvPr/>
         </p:nvSpPr>
@@ -15668,7 +15728,7 @@
       </p:sp>
       <p:sp>
         <p:nvSpPr>
-          <p:cNvPr id="105" name="Text 103"/>
+          <p:cNvPr id="108" name="Text 106"/>
           <p:cNvSpPr txBox="1"/>
           <p:nvPr/>
         </p:nvSpPr>
@@ -15707,7 +15767,7 @@
       </p:sp>
       <p:sp>
         <p:nvSpPr>
-          <p:cNvPr id="106" name="Text 104"/>
+          <p:cNvPr id="109" name="Text 107"/>
           <p:cNvSpPr txBox="1"/>
           <p:nvPr/>
         </p:nvSpPr>
@@ -15746,7 +15806,7 @@
       </p:sp>
       <p:sp>
         <p:nvSpPr>
-          <p:cNvPr id="107" name="Text 105"/>
+          <p:cNvPr id="110" name="Text 108"/>
           <p:cNvSpPr txBox="1"/>
           <p:nvPr/>
         </p:nvSpPr>
@@ -15785,7 +15845,7 @@
       </p:sp>
       <p:sp>
         <p:nvSpPr>
-          <p:cNvPr id="108" name="Text 106"/>
+          <p:cNvPr id="111" name="Text 109"/>
           <p:cNvSpPr txBox="1"/>
           <p:nvPr/>
         </p:nvSpPr>
@@ -15824,7 +15884,7 @@
       </p:sp>
       <p:sp>
         <p:nvSpPr>
-          <p:cNvPr id="109" name="Shape 107"/>
+          <p:cNvPr id="112" name="Shape 110"/>
           <p:cNvSpPr/>
           <p:nvPr/>
         </p:nvSpPr>
@@ -15844,7 +15904,7 @@
       </p:sp>
       <p:sp>
         <p:nvSpPr>
-          <p:cNvPr id="110" name="Text 108"/>
+          <p:cNvPr id="113" name="Text 111"/>
           <p:cNvSpPr txBox="1"/>
           <p:nvPr/>
         </p:nvSpPr>
@@ -15883,7 +15943,7 @@
       </p:sp>
       <p:sp>
         <p:nvSpPr>
-          <p:cNvPr id="111" name="Text 109"/>
+          <p:cNvPr id="114" name="Text 112"/>
           <p:cNvSpPr txBox="1"/>
           <p:nvPr/>
         </p:nvSpPr>
@@ -15922,7 +15982,7 @@
       </p:sp>
       <p:sp>
         <p:nvSpPr>
-          <p:cNvPr id="112" name="Text 110"/>
+          <p:cNvPr id="115" name="Text 113"/>
           <p:cNvSpPr txBox="1"/>
           <p:nvPr/>
         </p:nvSpPr>
@@ -15961,7 +16021,7 @@
       </p:sp>
       <p:sp>
         <p:nvSpPr>
-          <p:cNvPr id="113" name="Text 111"/>
+          <p:cNvPr id="116" name="Text 114"/>
           <p:cNvSpPr txBox="1"/>
           <p:nvPr/>
         </p:nvSpPr>
@@ -16000,7 +16060,7 @@
       </p:sp>
       <p:sp>
         <p:nvSpPr>
-          <p:cNvPr id="114" name="Shape 112"/>
+          <p:cNvPr id="117" name="Shape 115"/>
           <p:cNvSpPr/>
           <p:nvPr/>
         </p:nvSpPr>
@@ -16020,7 +16080,7 @@
       </p:sp>
       <p:sp>
         <p:nvSpPr>
-          <p:cNvPr id="115" name="Text 113"/>
+          <p:cNvPr id="118" name="Text 116"/>
           <p:cNvSpPr txBox="1"/>
           <p:nvPr/>
         </p:nvSpPr>
@@ -16059,7 +16119,7 @@
       </p:sp>
       <p:sp>
         <p:nvSpPr>
-          <p:cNvPr id="116" name="Text 114"/>
+          <p:cNvPr id="119" name="Text 117"/>
           <p:cNvSpPr txBox="1"/>
           <p:nvPr/>
         </p:nvSpPr>
@@ -16098,7 +16158,7 @@
       </p:sp>
       <p:sp>
         <p:nvSpPr>
-          <p:cNvPr id="117" name="Text 115"/>
+          <p:cNvPr id="120" name="Text 118"/>
           <p:cNvSpPr txBox="1"/>
           <p:nvPr/>
         </p:nvSpPr>
@@ -16137,7 +16197,7 @@
       </p:sp>
       <p:sp>
         <p:nvSpPr>
-          <p:cNvPr id="118" name="Text 116"/>
+          <p:cNvPr id="121" name="Text 119"/>
           <p:cNvSpPr txBox="1"/>
           <p:nvPr/>
         </p:nvSpPr>
@@ -16176,7 +16236,7 @@
       </p:sp>
       <p:sp>
         <p:nvSpPr>
-          <p:cNvPr id="119" name="Shape 117"/>
+          <p:cNvPr id="122" name="Shape 120"/>
           <p:cNvSpPr/>
           <p:nvPr/>
         </p:nvSpPr>
@@ -16196,7 +16256,7 @@
       </p:sp>
       <p:sp>
         <p:nvSpPr>
-          <p:cNvPr id="120" name="Text 118"/>
+          <p:cNvPr id="123" name="Text 121"/>
           <p:cNvSpPr txBox="1"/>
           <p:nvPr/>
         </p:nvSpPr>
@@ -16235,7 +16295,7 @@
       </p:sp>
       <p:sp>
         <p:nvSpPr>
-          <p:cNvPr id="121" name="Text 119"/>
+          <p:cNvPr id="124" name="Text 122"/>
           <p:cNvSpPr txBox="1"/>
           <p:nvPr/>
         </p:nvSpPr>
@@ -16274,7 +16334,7 @@
       </p:sp>
       <p:sp>
         <p:nvSpPr>
-          <p:cNvPr id="122" name="Text 120"/>
+          <p:cNvPr id="125" name="Text 123"/>
           <p:cNvSpPr txBox="1"/>
           <p:nvPr/>
         </p:nvSpPr>
@@ -16313,7 +16373,7 @@
       </p:sp>
       <p:sp>
         <p:nvSpPr>
-          <p:cNvPr id="123" name="Text 121"/>
+          <p:cNvPr id="126" name="Text 124"/>
           <p:cNvSpPr txBox="1"/>
           <p:nvPr/>
         </p:nvSpPr>
@@ -16352,7 +16412,7 @@
       </p:sp>
       <p:sp>
         <p:nvSpPr>
-          <p:cNvPr id="124" name="Shape 122"/>
+          <p:cNvPr id="127" name="Shape 125"/>
           <p:cNvSpPr/>
           <p:nvPr/>
         </p:nvSpPr>
@@ -16372,7 +16432,7 @@
       </p:sp>
       <p:sp>
         <p:nvSpPr>
-          <p:cNvPr id="125" name="Text 123"/>
+          <p:cNvPr id="128" name="Text 126"/>
           <p:cNvSpPr txBox="1"/>
           <p:nvPr/>
         </p:nvSpPr>
@@ -16411,7 +16471,7 @@
       </p:sp>
       <p:sp>
         <p:nvSpPr>
-          <p:cNvPr id="126" name="Text 124"/>
+          <p:cNvPr id="129" name="Text 127"/>
           <p:cNvSpPr txBox="1"/>
           <p:nvPr/>
         </p:nvSpPr>
@@ -16450,7 +16510,7 @@
       </p:sp>
       <p:sp>
         <p:nvSpPr>
-          <p:cNvPr id="127" name="Shape 125"/>
+          <p:cNvPr id="130" name="Shape 128"/>
           <p:cNvSpPr/>
           <p:nvPr/>
         </p:nvSpPr>
@@ -16470,7 +16530,7 @@
       </p:sp>
       <p:sp>
         <p:nvSpPr>
-          <p:cNvPr id="128" name="Text 126"/>
+          <p:cNvPr id="131" name="Text 129"/>
           <p:cNvSpPr txBox="1"/>
           <p:nvPr/>
         </p:nvSpPr>
@@ -16509,7 +16569,7 @@
       </p:sp>
       <p:sp>
         <p:nvSpPr>
-          <p:cNvPr id="129" name="Text 127"/>
+          <p:cNvPr id="132" name="Text 130"/>
           <p:cNvSpPr txBox="1"/>
           <p:nvPr/>
         </p:nvSpPr>
@@ -16548,7 +16608,7 @@
       </p:sp>
       <p:sp>
         <p:nvSpPr>
-          <p:cNvPr id="130" name="Shape 128"/>
+          <p:cNvPr id="133" name="Shape 131"/>
           <p:cNvSpPr/>
           <p:nvPr/>
         </p:nvSpPr>
@@ -16568,7 +16628,7 @@
       </p:sp>
       <p:sp>
         <p:nvSpPr>
-          <p:cNvPr id="131" name="Text 129"/>
+          <p:cNvPr id="134" name="Text 132"/>
           <p:cNvSpPr txBox="1"/>
           <p:nvPr/>
         </p:nvSpPr>
@@ -16607,7 +16667,7 @@
       </p:sp>
       <p:sp>
         <p:nvSpPr>
-          <p:cNvPr id="132" name="Text 130"/>
+          <p:cNvPr id="135" name="Text 133"/>
           <p:cNvSpPr txBox="1"/>
           <p:nvPr/>
         </p:nvSpPr>
@@ -16646,7 +16706,7 @@
       </p:sp>
       <p:sp>
         <p:nvSpPr>
-          <p:cNvPr id="133" name="Text 131"/>
+          <p:cNvPr id="136" name="Text 134"/>
           <p:cNvSpPr txBox="1"/>
           <p:nvPr/>
         </p:nvSpPr>
@@ -16685,7 +16745,7 @@
       </p:sp>
       <p:sp>
         <p:nvSpPr>
-          <p:cNvPr id="134" name="Text 132"/>
+          <p:cNvPr id="137" name="Text 135"/>
           <p:cNvSpPr txBox="1"/>
           <p:nvPr/>
         </p:nvSpPr>
@@ -16724,7 +16784,7 @@
       </p:sp>
       <p:sp>
         <p:nvSpPr>
-          <p:cNvPr id="135" name="Shape 133"/>
+          <p:cNvPr id="138" name="Shape 136"/>
           <p:cNvSpPr/>
           <p:nvPr/>
         </p:nvSpPr>
@@ -16744,7 +16804,7 @@
       </p:sp>
       <p:sp>
         <p:nvSpPr>
-          <p:cNvPr id="136" name="Text 134"/>
+          <p:cNvPr id="139" name="Text 137"/>
           <p:cNvSpPr txBox="1"/>
           <p:nvPr/>
         </p:nvSpPr>
@@ -16783,7 +16843,7 @@
       </p:sp>
       <p:sp>
         <p:nvSpPr>
-          <p:cNvPr id="137" name="Text 135"/>
+          <p:cNvPr id="140" name="Text 138"/>
           <p:cNvSpPr txBox="1"/>
           <p:nvPr/>
         </p:nvSpPr>
@@ -16822,7 +16882,7 @@
       </p:sp>
       <p:sp>
         <p:nvSpPr>
-          <p:cNvPr id="138" name="Text 136"/>
+          <p:cNvPr id="141" name="Text 139"/>
           <p:cNvSpPr txBox="1"/>
           <p:nvPr/>
         </p:nvSpPr>
@@ -16861,7 +16921,7 @@
       </p:sp>
       <p:sp>
         <p:nvSpPr>
-          <p:cNvPr id="139" name="Text 137"/>
+          <p:cNvPr id="142" name="Text 140"/>
           <p:cNvSpPr txBox="1"/>
           <p:nvPr/>
         </p:nvSpPr>
@@ -16900,7 +16960,7 @@
       </p:sp>
       <p:sp>
         <p:nvSpPr>
-          <p:cNvPr id="140" name="Shape 138"/>
+          <p:cNvPr id="143" name="Shape 141"/>
           <p:cNvSpPr/>
           <p:nvPr/>
         </p:nvSpPr>
@@ -16920,7 +16980,7 @@
       </p:sp>
       <p:sp>
         <p:nvSpPr>
-          <p:cNvPr id="141" name="Text 139"/>
+          <p:cNvPr id="144" name="Text 142"/>
           <p:cNvSpPr txBox="1"/>
           <p:nvPr/>
         </p:nvSpPr>
@@ -16959,7 +17019,7 @@
       </p:sp>
       <p:sp>
         <p:nvSpPr>
-          <p:cNvPr id="142" name="Text 140"/>
+          <p:cNvPr id="145" name="Text 143"/>
           <p:cNvSpPr txBox="1"/>
           <p:nvPr/>
         </p:nvSpPr>
@@ -16998,7 +17058,7 @@
       </p:sp>
       <p:sp>
         <p:nvSpPr>
-          <p:cNvPr id="143" name="Text 141"/>
+          <p:cNvPr id="146" name="Text 144"/>
           <p:cNvSpPr txBox="1"/>
           <p:nvPr/>
         </p:nvSpPr>
@@ -17037,7 +17097,7 @@
       </p:sp>
       <p:sp>
         <p:nvSpPr>
-          <p:cNvPr id="144" name="Text 142"/>
+          <p:cNvPr id="147" name="Text 145"/>
           <p:cNvSpPr txBox="1"/>
           <p:nvPr/>
         </p:nvSpPr>
@@ -17076,7 +17136,7 @@
       </p:sp>
       <p:sp>
         <p:nvSpPr>
-          <p:cNvPr id="145" name="Shape 143"/>
+          <p:cNvPr id="148" name="Shape 146"/>
           <p:cNvSpPr/>
           <p:nvPr/>
         </p:nvSpPr>
@@ -17096,7 +17156,7 @@
       </p:sp>
       <p:sp>
         <p:nvSpPr>
-          <p:cNvPr id="146" name="Text 144"/>
+          <p:cNvPr id="149" name="Text 147"/>
           <p:cNvSpPr txBox="1"/>
           <p:nvPr/>
         </p:nvSpPr>
@@ -17135,7 +17195,7 @@
       </p:sp>
       <p:sp>
         <p:nvSpPr>
-          <p:cNvPr id="147" name="Text 145"/>
+          <p:cNvPr id="150" name="Text 148"/>
           <p:cNvSpPr txBox="1"/>
           <p:nvPr/>
         </p:nvSpPr>
@@ -17174,7 +17234,7 @@
       </p:sp>
       <p:sp>
         <p:nvSpPr>
-          <p:cNvPr id="148" name="Text 146"/>
+          <p:cNvPr id="151" name="Text 149"/>
           <p:cNvSpPr txBox="1"/>
           <p:nvPr/>
         </p:nvSpPr>
@@ -17213,7 +17273,7 @@
       </p:sp>
       <p:sp>
         <p:nvSpPr>
-          <p:cNvPr id="149" name="Text 147"/>
+          <p:cNvPr id="152" name="Text 150"/>
           <p:cNvSpPr txBox="1"/>
           <p:nvPr/>
         </p:nvSpPr>
@@ -17252,7 +17312,7 @@
       </p:sp>
       <p:sp>
         <p:nvSpPr>
-          <p:cNvPr id="150" name="Shape 148"/>
+          <p:cNvPr id="153" name="Shape 151"/>
           <p:cNvSpPr/>
           <p:nvPr/>
         </p:nvSpPr>
@@ -17272,7 +17332,7 @@
       </p:sp>
       <p:sp>
         <p:nvSpPr>
-          <p:cNvPr id="151" name="Text 149"/>
+          <p:cNvPr id="154" name="Text 152"/>
           <p:cNvSpPr txBox="1"/>
           <p:nvPr/>
         </p:nvSpPr>
@@ -17311,7 +17371,7 @@
       </p:sp>
       <p:sp>
         <p:nvSpPr>
-          <p:cNvPr id="152" name="Text 150"/>
+          <p:cNvPr id="155" name="Text 153"/>
           <p:cNvSpPr txBox="1"/>
           <p:nvPr/>
         </p:nvSpPr>
@@ -17350,7 +17410,7 @@
       </p:sp>
       <p:sp>
         <p:nvSpPr>
-          <p:cNvPr id="153" name="Shape 151"/>
+          <p:cNvPr id="156" name="Shape 154"/>
           <p:cNvSpPr/>
           <p:nvPr/>
         </p:nvSpPr>
@@ -17370,7 +17430,7 @@
       </p:sp>
       <p:sp>
         <p:nvSpPr>
-          <p:cNvPr id="154" name="Text 152"/>
+          <p:cNvPr id="157" name="Text 155"/>
           <p:cNvSpPr txBox="1"/>
           <p:nvPr/>
         </p:nvSpPr>
@@ -17409,7 +17469,7 @@
       </p:sp>
       <p:sp>
         <p:nvSpPr>
-          <p:cNvPr id="155" name="Text 153"/>
+          <p:cNvPr id="158" name="Text 156"/>
           <p:cNvSpPr txBox="1"/>
           <p:nvPr/>
         </p:nvSpPr>
@@ -17448,7 +17508,7 @@
       </p:sp>
       <p:sp>
         <p:nvSpPr>
-          <p:cNvPr id="156" name="Shape 154"/>
+          <p:cNvPr id="159" name="Shape 157"/>
           <p:cNvSpPr/>
           <p:nvPr/>
         </p:nvSpPr>
@@ -17468,7 +17528,7 @@
       </p:sp>
       <p:sp>
         <p:nvSpPr>
-          <p:cNvPr id="157" name="Text 155"/>
+          <p:cNvPr id="160" name="Text 158"/>
           <p:cNvSpPr txBox="1"/>
           <p:nvPr/>
         </p:nvSpPr>
@@ -17507,7 +17567,7 @@
       </p:sp>
       <p:sp>
         <p:nvSpPr>
-          <p:cNvPr id="158" name="Text 156"/>
+          <p:cNvPr id="161" name="Text 159"/>
           <p:cNvSpPr txBox="1"/>
           <p:nvPr/>
         </p:nvSpPr>
@@ -17546,7 +17606,7 @@
       </p:sp>
       <p:sp>
         <p:nvSpPr>
-          <p:cNvPr id="159" name="Text 157"/>
+          <p:cNvPr id="162" name="Text 160"/>
           <p:cNvSpPr txBox="1"/>
           <p:nvPr/>
         </p:nvSpPr>
@@ -17585,7 +17645,7 @@
       </p:sp>
       <p:sp>
         <p:nvSpPr>
-          <p:cNvPr id="160" name="Text 158"/>
+          <p:cNvPr id="163" name="Text 161"/>
           <p:cNvSpPr txBox="1"/>
           <p:nvPr/>
         </p:nvSpPr>
@@ -17624,7 +17684,7 @@
       </p:sp>
       <p:sp>
         <p:nvSpPr>
-          <p:cNvPr id="161" name="Shape 159"/>
+          <p:cNvPr id="164" name="Shape 162"/>
           <p:cNvSpPr/>
           <p:nvPr/>
         </p:nvSpPr>
@@ -17644,7 +17704,7 @@
       </p:sp>
       <p:sp>
         <p:nvSpPr>
-          <p:cNvPr id="162" name="Text 160"/>
+          <p:cNvPr id="165" name="Text 163"/>
           <p:cNvSpPr txBox="1"/>
           <p:nvPr/>
         </p:nvSpPr>
@@ -17683,7 +17743,7 @@
       </p:sp>
       <p:sp>
         <p:nvSpPr>
-          <p:cNvPr id="163" name="Text 161"/>
+          <p:cNvPr id="166" name="Text 164"/>
           <p:cNvSpPr txBox="1"/>
           <p:nvPr/>
         </p:nvSpPr>
@@ -17722,7 +17782,27 @@
       </p:sp>
       <p:sp>
         <p:nvSpPr>
-          <p:cNvPr id="164" name="Text 162"/>
+          <p:cNvPr id="167" name="Shape 165"/>
+          <p:cNvSpPr/>
+          <p:nvPr/>
+        </p:nvSpPr>
+        <p:spPr>
+          <a:xfrm>
+            <a:off x="6163056" y="4815661"/>
+            <a:ext cx="5138928" cy="205471"/>
+          </a:xfrm>
+          <a:prstGeom prst="rect">
+            <a:avLst/>
+          </a:prstGeom>
+          <a:solidFill>
+            <a:srgbClr val="FBEBEA"/>
+          </a:solidFill>
+          <a:ln/>
+        </p:spPr>
+      </p:sp>
+      <p:sp>
+        <p:nvSpPr>
+          <p:cNvPr id="168" name="Text 166"/>
           <p:cNvSpPr txBox="1"/>
           <p:nvPr/>
         </p:nvSpPr>
@@ -17761,7 +17841,7 @@
       </p:sp>
       <p:sp>
         <p:nvSpPr>
-          <p:cNvPr id="165" name="Text 163"/>
+          <p:cNvPr id="169" name="Text 167"/>
           <p:cNvSpPr txBox="1"/>
           <p:nvPr/>
         </p:nvSpPr>
@@ -17800,7 +17880,7 @@
       </p:sp>
       <p:sp>
         <p:nvSpPr>
-          <p:cNvPr id="166" name="Shape 164"/>
+          <p:cNvPr id="170" name="Shape 168"/>
           <p:cNvSpPr/>
           <p:nvPr/>
         </p:nvSpPr>
@@ -17820,7 +17900,7 @@
       </p:sp>
       <p:sp>
         <p:nvSpPr>
-          <p:cNvPr id="167" name="Text 165"/>
+          <p:cNvPr id="171" name="Text 169"/>
           <p:cNvSpPr txBox="1"/>
           <p:nvPr/>
         </p:nvSpPr>
@@ -17859,7 +17939,7 @@
       </p:sp>
       <p:sp>
         <p:nvSpPr>
-          <p:cNvPr id="168" name="Text 166"/>
+          <p:cNvPr id="172" name="Text 170"/>
           <p:cNvSpPr txBox="1"/>
           <p:nvPr/>
         </p:nvSpPr>
@@ -17898,7 +17978,7 @@
       </p:sp>
       <p:sp>
         <p:nvSpPr>
-          <p:cNvPr id="169" name="Shape 167"/>
+          <p:cNvPr id="173" name="Shape 171"/>
           <p:cNvSpPr/>
           <p:nvPr/>
         </p:nvSpPr>
@@ -17918,7 +17998,7 @@
       </p:sp>
       <p:sp>
         <p:nvSpPr>
-          <p:cNvPr id="170" name="Text 168"/>
+          <p:cNvPr id="174" name="Text 172"/>
           <p:cNvSpPr txBox="1"/>
           <p:nvPr/>
         </p:nvSpPr>
@@ -17957,7 +18037,7 @@
       </p:sp>
       <p:sp>
         <p:nvSpPr>
-          <p:cNvPr id="171" name="Text 169"/>
+          <p:cNvPr id="175" name="Text 173"/>
           <p:cNvSpPr txBox="1"/>
           <p:nvPr/>
         </p:nvSpPr>
@@ -17996,7 +18076,7 @@
       </p:sp>
       <p:sp>
         <p:nvSpPr>
-          <p:cNvPr id="172" name="Shape 170"/>
+          <p:cNvPr id="176" name="Shape 174"/>
           <p:cNvSpPr/>
           <p:nvPr/>
         </p:nvSpPr>
@@ -18016,7 +18096,7 @@
       </p:sp>
       <p:sp>
         <p:nvSpPr>
-          <p:cNvPr id="173" name="Text 171"/>
+          <p:cNvPr id="177" name="Text 175"/>
           <p:cNvSpPr txBox="1"/>
           <p:nvPr/>
         </p:nvSpPr>
@@ -18055,7 +18135,7 @@
       </p:sp>
       <p:sp>
         <p:nvSpPr>
-          <p:cNvPr id="174" name="Text 172"/>
+          <p:cNvPr id="178" name="Text 176"/>
           <p:cNvSpPr txBox="1"/>
           <p:nvPr/>
         </p:nvSpPr>
@@ -18094,7 +18174,7 @@
       </p:sp>
       <p:sp>
         <p:nvSpPr>
-          <p:cNvPr id="175" name="Text 173"/>
+          <p:cNvPr id="179" name="Text 177"/>
           <p:cNvSpPr txBox="1"/>
           <p:nvPr/>
         </p:nvSpPr>
@@ -18133,7 +18213,7 @@
       </p:sp>
       <p:sp>
         <p:nvSpPr>
-          <p:cNvPr id="176" name="Text 174"/>
+          <p:cNvPr id="180" name="Text 178"/>
           <p:cNvSpPr txBox="1"/>
           <p:nvPr/>
         </p:nvSpPr>
@@ -18172,7 +18252,7 @@
       </p:sp>
       <p:sp>
         <p:nvSpPr>
-          <p:cNvPr id="177" name="Shape 175"/>
+          <p:cNvPr id="181" name="Shape 179"/>
           <p:cNvSpPr/>
           <p:nvPr/>
         </p:nvSpPr>
@@ -18192,7 +18272,7 @@
       </p:sp>
       <p:sp>
         <p:nvSpPr>
-          <p:cNvPr id="178" name="Text 176"/>
+          <p:cNvPr id="182" name="Text 180"/>
           <p:cNvSpPr txBox="1"/>
           <p:nvPr/>
         </p:nvSpPr>
@@ -18231,7 +18311,7 @@
       </p:sp>
       <p:sp>
         <p:nvSpPr>
-          <p:cNvPr id="179" name="Text 177"/>
+          <p:cNvPr id="183" name="Text 181"/>
           <p:cNvSpPr txBox="1"/>
           <p:nvPr/>
         </p:nvSpPr>
@@ -18270,7 +18350,7 @@
       </p:sp>
       <p:sp>
         <p:nvSpPr>
-          <p:cNvPr id="180" name="Shape 178"/>
+          <p:cNvPr id="184" name="Shape 182"/>
           <p:cNvSpPr/>
           <p:nvPr/>
         </p:nvSpPr>
@@ -18290,7 +18370,7 @@
       </p:sp>
       <p:sp>
         <p:nvSpPr>
-          <p:cNvPr id="181" name="Text 179"/>
+          <p:cNvPr id="185" name="Text 183"/>
           <p:cNvSpPr txBox="1"/>
           <p:nvPr/>
         </p:nvSpPr>
@@ -18329,7 +18409,7 @@
       </p:sp>
       <p:sp>
         <p:nvSpPr>
-          <p:cNvPr id="182" name="Text 180"/>
+          <p:cNvPr id="186" name="Text 184"/>
           <p:cNvSpPr txBox="1"/>
           <p:nvPr/>
         </p:nvSpPr>
@@ -18368,7 +18448,7 @@
       </p:sp>
       <p:sp>
         <p:nvSpPr>
-          <p:cNvPr id="183" name="Shape 181"/>
+          <p:cNvPr id="187" name="Shape 185"/>
           <p:cNvSpPr/>
           <p:nvPr/>
         </p:nvSpPr>
@@ -18388,7 +18468,7 @@
       </p:sp>
       <p:sp>
         <p:nvSpPr>
-          <p:cNvPr id="184" name="Text 182"/>
+          <p:cNvPr id="188" name="Text 186"/>
           <p:cNvSpPr txBox="1"/>
           <p:nvPr/>
         </p:nvSpPr>
@@ -18427,7 +18507,7 @@
       </p:sp>
       <p:sp>
         <p:nvSpPr>
-          <p:cNvPr id="185" name="Text 183"/>
+          <p:cNvPr id="189" name="Text 187"/>
           <p:cNvSpPr txBox="1"/>
           <p:nvPr/>
         </p:nvSpPr>
@@ -18466,7 +18546,7 @@
       </p:sp>
       <p:sp>
         <p:nvSpPr>
-          <p:cNvPr id="186" name="Shape 184"/>
+          <p:cNvPr id="190" name="Shape 188"/>
           <p:cNvSpPr/>
           <p:nvPr/>
         </p:nvSpPr>
@@ -18486,7 +18566,7 @@
       </p:sp>
       <p:sp>
         <p:nvSpPr>
-          <p:cNvPr id="187" name="Shape 185"/>
+          <p:cNvPr id="191" name="Shape 189"/>
           <p:cNvSpPr/>
           <p:nvPr/>
         </p:nvSpPr>
@@ -18506,7 +18586,7 @@
       </p:sp>
       <p:sp>
         <p:nvSpPr>
-          <p:cNvPr id="188" name="Shape 186"/>
+          <p:cNvPr id="192" name="Shape 190"/>
           <p:cNvSpPr/>
           <p:nvPr/>
         </p:nvSpPr>
@@ -18526,7 +18606,7 @@
       </p:sp>
       <p:sp>
         <p:nvSpPr>
-          <p:cNvPr id="189" name="Shape 187"/>
+          <p:cNvPr id="193" name="Shape 191"/>
           <p:cNvSpPr/>
           <p:nvPr/>
         </p:nvSpPr>
@@ -18539,14 +18619,14 @@
             <a:avLst/>
           </a:prstGeom>
           <a:solidFill>
-            <a:srgbClr val="E6F6EE"/>
+            <a:srgbClr val="EDF4FA"/>
           </a:solidFill>
           <a:ln/>
         </p:spPr>
       </p:sp>
       <p:sp>
         <p:nvSpPr>
-          <p:cNvPr id="190" name="Text 188"/>
+          <p:cNvPr id="194" name="Text 192"/>
           <p:cNvSpPr txBox="1"/>
           <p:nvPr/>
         </p:nvSpPr>
@@ -18571,13 +18651,13 @@
             <a:r>
               <a:rPr lang="en-US" sz="1600" b="1" dirty="0">
                 <a:solidFill>
-                  <a:srgbClr val="0B7A4A"/>
-                </a:solidFill>
-                <a:latin typeface="Inter" pitchFamily="34" charset="0"/>
-                <a:ea typeface="Inter" pitchFamily="34" charset="-122"/>
-                <a:cs typeface="Inter" pitchFamily="34" charset="-120"/>
-              </a:rPr>
-              <a:t>24 of 33 stores grew fixed ops net profit. Toyota Henderson added the most at +$1.42M; Chevy LV fell most at −$643K.</a:t>
+                  <a:srgbClr val="0B2C4A"/>
+                </a:solidFill>
+                <a:latin typeface="Inter" pitchFamily="34" charset="0"/>
+                <a:ea typeface="Inter" pitchFamily="34" charset="-122"/>
+                <a:cs typeface="Inter" pitchFamily="34" charset="-120"/>
+              </a:rPr>
+              <a:t>Lincoln, Subaru Prescott and GMC Prescott turned a 2025 loss into a profit (green rows); VW St George went from a profit to a loss (red row). 24 of 33 stores grew.</a:t>
             </a:r>
             <a:endParaRPr lang="en-US" sz="1600" dirty="0"/>
           </a:p>

</xml_diff>